<commit_message>
Add model deprecations & retirements to MD and PPTX
</commit_message>
<xml_diff>
--- a/whats-new-microsoft-ai-dec2025-feb2026.pptx
+++ b/whats-new-microsoft-ai-dec2025-feb2026.pptx
@@ -17,6 +17,8 @@
     <p:sldId id="265" r:id="rId16"/>
     <p:sldId id="266" r:id="rId17"/>
     <p:sldId id="267" r:id="rId18"/>
+    <p:sldId id="268" r:id="rId19"/>
+    <p:sldId id="269" r:id="rId20"/>
   </p:sldIdLst>
   <p:sldSz cx="12191695" cy="6858000" type="screen4x3"/>
   <p:notesSz cx="6858000" cy="9144000"/>
@@ -3303,6 +3305,1257 @@
 </file>
 
 <file path=ppt/slides/slide10.xml><?xml version="1.0" encoding="utf-8"?>
+<p:sld xmlns:a="http://schemas.openxmlformats.org/drawingml/2006/main" xmlns:p="http://schemas.openxmlformats.org/presentationml/2006/main" xmlns:r="http://schemas.openxmlformats.org/officeDocument/2006/relationships">
+  <p:cSld>
+    <p:bg>
+      <p:bgPr>
+        <a:solidFill>
+          <a:srgbClr val="1B1B1B"/>
+        </a:solidFill>
+        <a:effectLst/>
+      </p:bgPr>
+    </p:bg>
+    <p:spTree>
+      <p:nvGrpSpPr>
+        <p:cNvPr id="1" name=""/>
+        <p:cNvGrpSpPr/>
+        <p:nvPr/>
+      </p:nvGrpSpPr>
+      <p:grpSpPr/>
+      <p:sp>
+        <p:nvSpPr>
+          <p:cNvPr id="2" name="Rectangle 1"/>
+          <p:cNvSpPr/>
+          <p:nvPr/>
+        </p:nvSpPr>
+        <p:spPr>
+          <a:xfrm>
+            <a:off x="0" y="0"/>
+            <a:ext cx="12191695" cy="137160"/>
+          </a:xfrm>
+          <a:prstGeom prst="rect">
+            <a:avLst/>
+          </a:prstGeom>
+          <a:solidFill>
+            <a:srgbClr val="0078D4"/>
+          </a:solidFill>
+          <a:ln>
+            <a:noFill/>
+          </a:ln>
+        </p:spPr>
+        <p:style>
+          <a:lnRef idx="1">
+            <a:schemeClr val="accent1"/>
+          </a:lnRef>
+          <a:fillRef idx="3">
+            <a:schemeClr val="accent1"/>
+          </a:fillRef>
+          <a:effectRef idx="2">
+            <a:schemeClr val="accent1"/>
+          </a:effectRef>
+          <a:fontRef idx="minor">
+            <a:schemeClr val="lt1"/>
+          </a:fontRef>
+        </p:style>
+        <p:txBody>
+          <a:bodyPr rtlCol="0" anchor="ctr"/>
+          <a:lstStyle/>
+          <a:p>
+            <a:pPr algn="ctr"/>
+          </a:p>
+        </p:txBody>
+      </p:sp>
+      <p:sp>
+        <p:nvSpPr>
+          <p:cNvPr id="3" name="TextBox 2"/>
+          <p:cNvSpPr txBox="1"/>
+          <p:nvPr/>
+        </p:nvSpPr>
+        <p:spPr>
+          <a:xfrm>
+            <a:off x="731520" y="365760"/>
+            <a:ext cx="10058400" cy="640080"/>
+          </a:xfrm>
+          <a:prstGeom prst="rect">
+            <a:avLst/>
+          </a:prstGeom>
+          <a:noFill/>
+        </p:spPr>
+        <p:txBody>
+          <a:bodyPr wrap="square">
+            <a:spAutoFit/>
+          </a:bodyPr>
+          <a:lstStyle/>
+          <a:p>
+            <a:pPr algn="l">
+              <a:defRPr sz="3400" b="1">
+                <a:solidFill>
+                  <a:srgbClr val="FFFFFF"/>
+                </a:solidFill>
+                <a:latin typeface="Segoe UI"/>
+              </a:defRPr>
+            </a:pPr>
+            <a:r>
+              <a:t>Model Deprecations &amp; Retirements</a:t>
+            </a:r>
+          </a:p>
+        </p:txBody>
+      </p:sp>
+      <p:sp>
+        <p:nvSpPr>
+          <p:cNvPr id="4" name="Rectangle 3"/>
+          <p:cNvSpPr/>
+          <p:nvPr/>
+        </p:nvSpPr>
+        <p:spPr>
+          <a:xfrm>
+            <a:off x="457200" y="1005840"/>
+            <a:ext cx="1097280" cy="50800"/>
+          </a:xfrm>
+          <a:prstGeom prst="rect">
+            <a:avLst/>
+          </a:prstGeom>
+          <a:solidFill>
+            <a:srgbClr val="0078D4"/>
+          </a:solidFill>
+          <a:ln>
+            <a:noFill/>
+          </a:ln>
+        </p:spPr>
+        <p:style>
+          <a:lnRef idx="1">
+            <a:schemeClr val="accent1"/>
+          </a:lnRef>
+          <a:fillRef idx="3">
+            <a:schemeClr val="accent1"/>
+          </a:fillRef>
+          <a:effectRef idx="2">
+            <a:schemeClr val="accent1"/>
+          </a:effectRef>
+          <a:fontRef idx="minor">
+            <a:schemeClr val="lt1"/>
+          </a:fontRef>
+        </p:style>
+        <p:txBody>
+          <a:bodyPr rtlCol="0" anchor="ctr"/>
+          <a:lstStyle/>
+          <a:p>
+            <a:pPr algn="ctr"/>
+          </a:p>
+        </p:txBody>
+      </p:sp>
+      <p:graphicFrame>
+        <p:nvGraphicFramePr>
+          <p:cNvPr id="5" name="Table 4"/>
+          <p:cNvGraphicFramePr>
+            <a:graphicFrameLocks noGrp="1"/>
+          </p:cNvGraphicFramePr>
+          <p:nvPr/>
+        </p:nvGraphicFramePr>
+        <p:xfrm>
+          <a:off x="457200" y="1371600"/>
+          <a:ext cx="11247120" cy="4206240"/>
+        </p:xfrm>
+        <a:graphic>
+          <a:graphicData uri="http://schemas.openxmlformats.org/drawingml/2006/table">
+            <a:tbl>
+              <a:tblPr firstRow="1" bandRow="1">
+                <a:tableStyleId>{5C22544A-7EE6-4342-B048-85BDC9FD1C3A}</a:tableStyleId>
+              </a:tblPr>
+              <a:tblGrid>
+                <a:gridCol w="3200400"/>
+                <a:gridCol w="2011680"/>
+                <a:gridCol w="3474720"/>
+                <a:gridCol w="2560320"/>
+              </a:tblGrid>
+              <a:tr h="525780">
+                <a:tc>
+                  <a:txBody>
+                    <a:bodyPr/>
+                    <a:lstStyle/>
+                    <a:p>
+                      <a:pPr algn="l"/>
+                      <a:r>
+                        <a:rPr sz="1400" b="1">
+                          <a:solidFill>
+                            <a:srgbClr val="FFFFFF"/>
+                          </a:solidFill>
+                          <a:latin typeface="Segoe UI"/>
+                        </a:rPr>
+                        <a:t>Model</a:t>
+                      </a:r>
+                    </a:p>
+                  </a:txBody>
+                  <a:tcPr anchor="ctr">
+                    <a:solidFill>
+                      <a:srgbClr val="0078D4"/>
+                    </a:solidFill>
+                  </a:tcPr>
+                </a:tc>
+                <a:tc>
+                  <a:txBody>
+                    <a:bodyPr/>
+                    <a:lstStyle/>
+                    <a:p>
+                      <a:pPr algn="l"/>
+                      <a:r>
+                        <a:rPr sz="1400" b="1">
+                          <a:solidFill>
+                            <a:srgbClr val="FFFFFF"/>
+                          </a:solidFill>
+                          <a:latin typeface="Segoe UI"/>
+                        </a:rPr>
+                        <a:t>Type</a:t>
+                      </a:r>
+                    </a:p>
+                  </a:txBody>
+                  <a:tcPr anchor="ctr">
+                    <a:solidFill>
+                      <a:srgbClr val="0078D4"/>
+                    </a:solidFill>
+                  </a:tcPr>
+                </a:tc>
+                <a:tc>
+                  <a:txBody>
+                    <a:bodyPr/>
+                    <a:lstStyle/>
+                    <a:p>
+                      <a:pPr algn="l"/>
+                      <a:r>
+                        <a:rPr sz="1400" b="1">
+                          <a:solidFill>
+                            <a:srgbClr val="FFFFFF"/>
+                          </a:solidFill>
+                          <a:latin typeface="Segoe UI"/>
+                        </a:rPr>
+                        <a:t>Deprecation</a:t>
+                      </a:r>
+                    </a:p>
+                  </a:txBody>
+                  <a:tcPr anchor="ctr">
+                    <a:solidFill>
+                      <a:srgbClr val="0078D4"/>
+                    </a:solidFill>
+                  </a:tcPr>
+                </a:tc>
+                <a:tc>
+                  <a:txBody>
+                    <a:bodyPr/>
+                    <a:lstStyle/>
+                    <a:p>
+                      <a:pPr algn="l"/>
+                      <a:r>
+                        <a:rPr sz="1400" b="1">
+                          <a:solidFill>
+                            <a:srgbClr val="FFFFFF"/>
+                          </a:solidFill>
+                          <a:latin typeface="Segoe UI"/>
+                        </a:rPr>
+                        <a:t>Retirement</a:t>
+                      </a:r>
+                    </a:p>
+                  </a:txBody>
+                  <a:tcPr anchor="ctr">
+                    <a:solidFill>
+                      <a:srgbClr val="0078D4"/>
+                    </a:solidFill>
+                  </a:tcPr>
+                </a:tc>
+              </a:tr>
+              <a:tr h="525780">
+                <a:tc>
+                  <a:txBody>
+                    <a:bodyPr/>
+                    <a:lstStyle/>
+                    <a:p>
+                      <a:pPr algn="l"/>
+                      <a:r>
+                        <a:rPr sz="1300" b="0">
+                          <a:solidFill>
+                            <a:srgbClr val="FFFFFF"/>
+                          </a:solidFill>
+                          <a:latin typeface="Segoe UI"/>
+                        </a:rPr>
+                        <a:t>o1 (2024-12-17)</a:t>
+                      </a:r>
+                    </a:p>
+                  </a:txBody>
+                  <a:tcPr anchor="ctr">
+                    <a:solidFill>
+                      <a:srgbClr val="2A2A2A"/>
+                    </a:solidFill>
+                  </a:tcPr>
+                </a:tc>
+                <a:tc>
+                  <a:txBody>
+                    <a:bodyPr/>
+                    <a:lstStyle/>
+                    <a:p>
+                      <a:pPr algn="l"/>
+                      <a:r>
+                        <a:rPr sz="1300" b="0">
+                          <a:solidFill>
+                            <a:srgbClr val="FFFFFF"/>
+                          </a:solidFill>
+                          <a:latin typeface="Segoe UI"/>
+                        </a:rPr>
+                        <a:t>Standard</a:t>
+                      </a:r>
+                    </a:p>
+                  </a:txBody>
+                  <a:tcPr anchor="ctr">
+                    <a:solidFill>
+                      <a:srgbClr val="2A2A2A"/>
+                    </a:solidFill>
+                  </a:tcPr>
+                </a:tc>
+                <a:tc>
+                  <a:txBody>
+                    <a:bodyPr/>
+                    <a:lstStyle/>
+                    <a:p>
+                      <a:pPr algn="l"/>
+                      <a:r>
+                        <a:rPr sz="1300" b="0">
+                          <a:solidFill>
+                            <a:srgbClr val="FFFFFF"/>
+                          </a:solidFill>
+                          <a:latin typeface="Segoe UI"/>
+                        </a:rPr>
+                        <a:t>Dec 17, 2025</a:t>
+                      </a:r>
+                    </a:p>
+                  </a:txBody>
+                  <a:tcPr anchor="ctr">
+                    <a:solidFill>
+                      <a:srgbClr val="2A2A2A"/>
+                    </a:solidFill>
+                  </a:tcPr>
+                </a:tc>
+                <a:tc>
+                  <a:txBody>
+                    <a:bodyPr/>
+                    <a:lstStyle/>
+                    <a:p>
+                      <a:pPr algn="l"/>
+                      <a:r>
+                        <a:rPr sz="1300" b="0">
+                          <a:solidFill>
+                            <a:srgbClr val="FFFFFF"/>
+                          </a:solidFill>
+                          <a:latin typeface="Segoe UI"/>
+                        </a:rPr>
+                        <a:t>Jul 15, 2026</a:t>
+                      </a:r>
+                    </a:p>
+                  </a:txBody>
+                  <a:tcPr anchor="ctr">
+                    <a:solidFill>
+                      <a:srgbClr val="2A2A2A"/>
+                    </a:solidFill>
+                  </a:tcPr>
+                </a:tc>
+              </a:tr>
+              <a:tr h="525780">
+                <a:tc>
+                  <a:txBody>
+                    <a:bodyPr/>
+                    <a:lstStyle/>
+                    <a:p>
+                      <a:pPr algn="l"/>
+                      <a:r>
+                        <a:rPr sz="1300" b="0">
+                          <a:solidFill>
+                            <a:srgbClr val="FFFFFF"/>
+                          </a:solidFill>
+                          <a:latin typeface="Segoe UI"/>
+                        </a:rPr>
+                        <a:t>o3-mini (2025-01-31)</a:t>
+                      </a:r>
+                    </a:p>
+                  </a:txBody>
+                  <a:tcPr anchor="ctr">
+                    <a:solidFill>
+                      <a:srgbClr val="222222"/>
+                    </a:solidFill>
+                  </a:tcPr>
+                </a:tc>
+                <a:tc>
+                  <a:txBody>
+                    <a:bodyPr/>
+                    <a:lstStyle/>
+                    <a:p>
+                      <a:pPr algn="l"/>
+                      <a:r>
+                        <a:rPr sz="1300" b="0">
+                          <a:solidFill>
+                            <a:srgbClr val="FFFFFF"/>
+                          </a:solidFill>
+                          <a:latin typeface="Segoe UI"/>
+                        </a:rPr>
+                        <a:t>Standard</a:t>
+                      </a:r>
+                    </a:p>
+                  </a:txBody>
+                  <a:tcPr anchor="ctr">
+                    <a:solidFill>
+                      <a:srgbClr val="222222"/>
+                    </a:solidFill>
+                  </a:tcPr>
+                </a:tc>
+                <a:tc>
+                  <a:txBody>
+                    <a:bodyPr/>
+                    <a:lstStyle/>
+                    <a:p>
+                      <a:pPr algn="l"/>
+                      <a:r>
+                        <a:rPr sz="1300" b="0">
+                          <a:solidFill>
+                            <a:srgbClr val="FFFFFF"/>
+                          </a:solidFill>
+                          <a:latin typeface="Segoe UI"/>
+                        </a:rPr>
+                        <a:t>Jan 31, 2026</a:t>
+                      </a:r>
+                    </a:p>
+                  </a:txBody>
+                  <a:tcPr anchor="ctr">
+                    <a:solidFill>
+                      <a:srgbClr val="222222"/>
+                    </a:solidFill>
+                  </a:tcPr>
+                </a:tc>
+                <a:tc>
+                  <a:txBody>
+                    <a:bodyPr/>
+                    <a:lstStyle/>
+                    <a:p>
+                      <a:pPr algn="l"/>
+                      <a:r>
+                        <a:rPr sz="1300" b="0">
+                          <a:solidFill>
+                            <a:srgbClr val="FFFFFF"/>
+                          </a:solidFill>
+                          <a:latin typeface="Segoe UI"/>
+                        </a:rPr>
+                        <a:t>Aug 2, 2026</a:t>
+                      </a:r>
+                    </a:p>
+                  </a:txBody>
+                  <a:tcPr anchor="ctr">
+                    <a:solidFill>
+                      <a:srgbClr val="222222"/>
+                    </a:solidFill>
+                  </a:tcPr>
+                </a:tc>
+              </a:tr>
+              <a:tr h="525780">
+                <a:tc>
+                  <a:txBody>
+                    <a:bodyPr/>
+                    <a:lstStyle/>
+                    <a:p>
+                      <a:pPr algn="l"/>
+                      <a:r>
+                        <a:rPr sz="1300" b="0">
+                          <a:solidFill>
+                            <a:srgbClr val="FFFFFF"/>
+                          </a:solidFill>
+                          <a:latin typeface="Segoe UI"/>
+                        </a:rPr>
+                        <a:t>gpt-5-chat (preview)</a:t>
+                      </a:r>
+                    </a:p>
+                  </a:txBody>
+                  <a:tcPr anchor="ctr">
+                    <a:solidFill>
+                      <a:srgbClr val="2A2A2A"/>
+                    </a:solidFill>
+                  </a:tcPr>
+                </a:tc>
+                <a:tc>
+                  <a:txBody>
+                    <a:bodyPr/>
+                    <a:lstStyle/>
+                    <a:p>
+                      <a:pPr algn="l"/>
+                      <a:r>
+                        <a:rPr sz="1300" b="0">
+                          <a:solidFill>
+                            <a:srgbClr val="FFFFFF"/>
+                          </a:solidFill>
+                          <a:latin typeface="Segoe UI"/>
+                        </a:rPr>
+                        <a:t>Preview</a:t>
+                      </a:r>
+                    </a:p>
+                  </a:txBody>
+                  <a:tcPr anchor="ctr">
+                    <a:solidFill>
+                      <a:srgbClr val="2A2A2A"/>
+                    </a:solidFill>
+                  </a:tcPr>
+                </a:tc>
+                <a:tc>
+                  <a:txBody>
+                    <a:bodyPr/>
+                    <a:lstStyle/>
+                    <a:p>
+                      <a:pPr algn="l"/>
+                      <a:r>
+                        <a:rPr sz="1300" b="0">
+                          <a:solidFill>
+                            <a:srgbClr val="FFFFFF"/>
+                          </a:solidFill>
+                          <a:latin typeface="Segoe UI"/>
+                        </a:rPr>
+                        <a:t>–</a:t>
+                      </a:r>
+                    </a:p>
+                  </a:txBody>
+                  <a:tcPr anchor="ctr">
+                    <a:solidFill>
+                      <a:srgbClr val="2A2A2A"/>
+                    </a:solidFill>
+                  </a:tcPr>
+                </a:tc>
+                <a:tc>
+                  <a:txBody>
+                    <a:bodyPr/>
+                    <a:lstStyle/>
+                    <a:p>
+                      <a:pPr algn="l"/>
+                      <a:r>
+                        <a:rPr sz="1300" b="0">
+                          <a:solidFill>
+                            <a:srgbClr val="FFFFFF"/>
+                          </a:solidFill>
+                          <a:latin typeface="Segoe UI"/>
+                        </a:rPr>
+                        <a:t>Mar 1, 2026</a:t>
+                      </a:r>
+                    </a:p>
+                  </a:txBody>
+                  <a:tcPr anchor="ctr">
+                    <a:solidFill>
+                      <a:srgbClr val="2A2A2A"/>
+                    </a:solidFill>
+                  </a:tcPr>
+                </a:tc>
+              </a:tr>
+              <a:tr h="525780">
+                <a:tc>
+                  <a:txBody>
+                    <a:bodyPr/>
+                    <a:lstStyle/>
+                    <a:p>
+                      <a:pPr algn="l"/>
+                      <a:r>
+                        <a:rPr sz="1300" b="0">
+                          <a:solidFill>
+                            <a:srgbClr val="FFFFFF"/>
+                          </a:solidFill>
+                          <a:latin typeface="Segoe UI"/>
+                        </a:rPr>
+                        <a:t>gpt-4o (all GA versions)</a:t>
+                      </a:r>
+                    </a:p>
+                  </a:txBody>
+                  <a:tcPr anchor="ctr">
+                    <a:solidFill>
+                      <a:srgbClr val="222222"/>
+                    </a:solidFill>
+                  </a:tcPr>
+                </a:tc>
+                <a:tc>
+                  <a:txBody>
+                    <a:bodyPr/>
+                    <a:lstStyle/>
+                    <a:p>
+                      <a:pPr algn="l"/>
+                      <a:r>
+                        <a:rPr sz="1300" b="0">
+                          <a:solidFill>
+                            <a:srgbClr val="FFFFFF"/>
+                          </a:solidFill>
+                          <a:latin typeface="Segoe UI"/>
+                        </a:rPr>
+                        <a:t>Standard</a:t>
+                      </a:r>
+                    </a:p>
+                  </a:txBody>
+                  <a:tcPr anchor="ctr">
+                    <a:solidFill>
+                      <a:srgbClr val="222222"/>
+                    </a:solidFill>
+                  </a:tcPr>
+                </a:tc>
+                <a:tc>
+                  <a:txBody>
+                    <a:bodyPr/>
+                    <a:lstStyle/>
+                    <a:p>
+                      <a:pPr algn="l"/>
+                      <a:r>
+                        <a:rPr sz="1300" b="0">
+                          <a:solidFill>
+                            <a:srgbClr val="FFFFFF"/>
+                          </a:solidFill>
+                          <a:latin typeface="Segoe UI"/>
+                        </a:rPr>
+                        <a:t>–</a:t>
+                      </a:r>
+                    </a:p>
+                  </a:txBody>
+                  <a:tcPr anchor="ctr">
+                    <a:solidFill>
+                      <a:srgbClr val="222222"/>
+                    </a:solidFill>
+                  </a:tcPr>
+                </a:tc>
+                <a:tc>
+                  <a:txBody>
+                    <a:bodyPr/>
+                    <a:lstStyle/>
+                    <a:p>
+                      <a:pPr algn="l"/>
+                      <a:r>
+                        <a:rPr sz="1300" b="0">
+                          <a:solidFill>
+                            <a:srgbClr val="FFFFFF"/>
+                          </a:solidFill>
+                          <a:latin typeface="Segoe UI"/>
+                        </a:rPr>
+                        <a:t>Mar 31, 2026</a:t>
+                      </a:r>
+                    </a:p>
+                  </a:txBody>
+                  <a:tcPr anchor="ctr">
+                    <a:solidFill>
+                      <a:srgbClr val="222222"/>
+                    </a:solidFill>
+                  </a:tcPr>
+                </a:tc>
+              </a:tr>
+              <a:tr h="525780">
+                <a:tc>
+                  <a:txBody>
+                    <a:bodyPr/>
+                    <a:lstStyle/>
+                    <a:p>
+                      <a:pPr algn="l"/>
+                      <a:r>
+                        <a:rPr sz="1300" b="0">
+                          <a:solidFill>
+                            <a:srgbClr val="FFFFFF"/>
+                          </a:solidFill>
+                          <a:latin typeface="Segoe UI"/>
+                        </a:rPr>
+                        <a:t>gpt-4o-mini (2024-07-18)</a:t>
+                      </a:r>
+                    </a:p>
+                  </a:txBody>
+                  <a:tcPr anchor="ctr">
+                    <a:solidFill>
+                      <a:srgbClr val="2A2A2A"/>
+                    </a:solidFill>
+                  </a:tcPr>
+                </a:tc>
+                <a:tc>
+                  <a:txBody>
+                    <a:bodyPr/>
+                    <a:lstStyle/>
+                    <a:p>
+                      <a:pPr algn="l"/>
+                      <a:r>
+                        <a:rPr sz="1300" b="0">
+                          <a:solidFill>
+                            <a:srgbClr val="FFFFFF"/>
+                          </a:solidFill>
+                          <a:latin typeface="Segoe UI"/>
+                        </a:rPr>
+                        <a:t>Standard</a:t>
+                      </a:r>
+                    </a:p>
+                  </a:txBody>
+                  <a:tcPr anchor="ctr">
+                    <a:solidFill>
+                      <a:srgbClr val="2A2A2A"/>
+                    </a:solidFill>
+                  </a:tcPr>
+                </a:tc>
+                <a:tc>
+                  <a:txBody>
+                    <a:bodyPr/>
+                    <a:lstStyle/>
+                    <a:p>
+                      <a:pPr algn="l"/>
+                      <a:r>
+                        <a:rPr sz="1300" b="0">
+                          <a:solidFill>
+                            <a:srgbClr val="FFFFFF"/>
+                          </a:solidFill>
+                          <a:latin typeface="Segoe UI"/>
+                        </a:rPr>
+                        <a:t>–</a:t>
+                      </a:r>
+                    </a:p>
+                  </a:txBody>
+                  <a:tcPr anchor="ctr">
+                    <a:solidFill>
+                      <a:srgbClr val="2A2A2A"/>
+                    </a:solidFill>
+                  </a:tcPr>
+                </a:tc>
+                <a:tc>
+                  <a:txBody>
+                    <a:bodyPr/>
+                    <a:lstStyle/>
+                    <a:p>
+                      <a:pPr algn="l"/>
+                      <a:r>
+                        <a:rPr sz="1300" b="0">
+                          <a:solidFill>
+                            <a:srgbClr val="FFFFFF"/>
+                          </a:solidFill>
+                          <a:latin typeface="Segoe UI"/>
+                        </a:rPr>
+                        <a:t>Mar 31, 2026</a:t>
+                      </a:r>
+                    </a:p>
+                  </a:txBody>
+                  <a:tcPr anchor="ctr">
+                    <a:solidFill>
+                      <a:srgbClr val="2A2A2A"/>
+                    </a:solidFill>
+                  </a:tcPr>
+                </a:tc>
+              </a:tr>
+              <a:tr h="525780">
+                <a:tc>
+                  <a:txBody>
+                    <a:bodyPr/>
+                    <a:lstStyle/>
+                    <a:p>
+                      <a:pPr algn="l"/>
+                      <a:r>
+                        <a:rPr sz="1300" b="0">
+                          <a:solidFill>
+                            <a:srgbClr val="FFFFFF"/>
+                          </a:solidFill>
+                          <a:latin typeface="Segoe UI"/>
+                        </a:rPr>
+                        <a:t>gpt-4.1 family</a:t>
+                      </a:r>
+                    </a:p>
+                  </a:txBody>
+                  <a:tcPr anchor="ctr">
+                    <a:solidFill>
+                      <a:srgbClr val="222222"/>
+                    </a:solidFill>
+                  </a:tcPr>
+                </a:tc>
+                <a:tc>
+                  <a:txBody>
+                    <a:bodyPr/>
+                    <a:lstStyle/>
+                    <a:p>
+                      <a:pPr algn="l"/>
+                      <a:r>
+                        <a:rPr sz="1300" b="0">
+                          <a:solidFill>
+                            <a:srgbClr val="FFFFFF"/>
+                          </a:solidFill>
+                          <a:latin typeface="Segoe UI"/>
+                        </a:rPr>
+                        <a:t>GA</a:t>
+                      </a:r>
+                    </a:p>
+                  </a:txBody>
+                  <a:tcPr anchor="ctr">
+                    <a:solidFill>
+                      <a:srgbClr val="222222"/>
+                    </a:solidFill>
+                  </a:tcPr>
+                </a:tc>
+                <a:tc>
+                  <a:txBody>
+                    <a:bodyPr/>
+                    <a:lstStyle/>
+                    <a:p>
+                      <a:pPr algn="l"/>
+                      <a:r>
+                        <a:rPr sz="1300" b="0">
+                          <a:solidFill>
+                            <a:srgbClr val="FFFFFF"/>
+                          </a:solidFill>
+                          <a:latin typeface="Segoe UI"/>
+                        </a:rPr>
+                        <a:t>Apr 14, 2026 (dep)</a:t>
+                      </a:r>
+                    </a:p>
+                  </a:txBody>
+                  <a:tcPr anchor="ctr">
+                    <a:solidFill>
+                      <a:srgbClr val="222222"/>
+                    </a:solidFill>
+                  </a:tcPr>
+                </a:tc>
+                <a:tc>
+                  <a:txBody>
+                    <a:bodyPr/>
+                    <a:lstStyle/>
+                    <a:p>
+                      <a:pPr algn="l"/>
+                      <a:r>
+                        <a:rPr sz="1300" b="0">
+                          <a:solidFill>
+                            <a:srgbClr val="FFFFFF"/>
+                          </a:solidFill>
+                          <a:latin typeface="Segoe UI"/>
+                        </a:rPr>
+                        <a:t>Oct 14, 2026</a:t>
+                      </a:r>
+                    </a:p>
+                  </a:txBody>
+                  <a:tcPr anchor="ctr">
+                    <a:solidFill>
+                      <a:srgbClr val="222222"/>
+                    </a:solidFill>
+                  </a:tcPr>
+                </a:tc>
+              </a:tr>
+              <a:tr h="525780">
+                <a:tc>
+                  <a:txBody>
+                    <a:bodyPr/>
+                    <a:lstStyle/>
+                    <a:p>
+                      <a:pPr algn="l"/>
+                      <a:r>
+                        <a:rPr sz="1300" b="0">
+                          <a:solidFill>
+                            <a:srgbClr val="FFFFFF"/>
+                          </a:solidFill>
+                          <a:latin typeface="Segoe UI"/>
+                        </a:rPr>
+                        <a:t>gpt-4.1-nano</a:t>
+                      </a:r>
+                    </a:p>
+                  </a:txBody>
+                  <a:tcPr anchor="ctr">
+                    <a:solidFill>
+                      <a:srgbClr val="2A2A2A"/>
+                    </a:solidFill>
+                  </a:tcPr>
+                </a:tc>
+                <a:tc>
+                  <a:txBody>
+                    <a:bodyPr/>
+                    <a:lstStyle/>
+                    <a:p>
+                      <a:pPr algn="l"/>
+                      <a:r>
+                        <a:rPr sz="1300" b="0">
+                          <a:solidFill>
+                            <a:srgbClr val="FFFFFF"/>
+                          </a:solidFill>
+                          <a:latin typeface="Segoe UI"/>
+                        </a:rPr>
+                        <a:t>GA</a:t>
+                      </a:r>
+                    </a:p>
+                  </a:txBody>
+                  <a:tcPr anchor="ctr">
+                    <a:solidFill>
+                      <a:srgbClr val="2A2A2A"/>
+                    </a:solidFill>
+                  </a:tcPr>
+                </a:tc>
+                <a:tc>
+                  <a:txBody>
+                    <a:bodyPr/>
+                    <a:lstStyle/>
+                    <a:p>
+                      <a:pPr algn="l"/>
+                      <a:r>
+                        <a:rPr sz="1300" b="0">
+                          <a:solidFill>
+                            <a:srgbClr val="FFFFFF"/>
+                          </a:solidFill>
+                          <a:latin typeface="Segoe UI"/>
+                        </a:rPr>
+                        <a:t>Apr 14, 2026 (dep)</a:t>
+                      </a:r>
+                    </a:p>
+                  </a:txBody>
+                  <a:tcPr anchor="ctr">
+                    <a:solidFill>
+                      <a:srgbClr val="2A2A2A"/>
+                    </a:solidFill>
+                  </a:tcPr>
+                </a:tc>
+                <a:tc>
+                  <a:txBody>
+                    <a:bodyPr/>
+                    <a:lstStyle/>
+                    <a:p>
+                      <a:pPr algn="l"/>
+                      <a:r>
+                        <a:rPr sz="1300" b="0">
+                          <a:solidFill>
+                            <a:srgbClr val="FFFFFF"/>
+                          </a:solidFill>
+                          <a:latin typeface="Segoe UI"/>
+                        </a:rPr>
+                        <a:t>Oct 14, 2026</a:t>
+                      </a:r>
+                    </a:p>
+                  </a:txBody>
+                  <a:tcPr anchor="ctr">
+                    <a:solidFill>
+                      <a:srgbClr val="2A2A2A"/>
+                    </a:solidFill>
+                  </a:tcPr>
+                </a:tc>
+              </a:tr>
+            </a:tbl>
+          </a:graphicData>
+        </a:graphic>
+      </p:graphicFrame>
+      <p:sp>
+        <p:nvSpPr>
+          <p:cNvPr id="6" name="TextBox 5"/>
+          <p:cNvSpPr txBox="1"/>
+          <p:nvPr/>
+        </p:nvSpPr>
+        <p:spPr>
+          <a:xfrm>
+            <a:off x="457200" y="5760720"/>
+            <a:ext cx="11247120" cy="365760"/>
+          </a:xfrm>
+          <a:prstGeom prst="rect">
+            <a:avLst/>
+          </a:prstGeom>
+          <a:noFill/>
+        </p:spPr>
+        <p:txBody>
+          <a:bodyPr wrap="square">
+            <a:spAutoFit/>
+          </a:bodyPr>
+          <a:lstStyle/>
+          <a:p>
+            <a:pPr algn="l">
+              <a:defRPr sz="1300" b="0">
+                <a:solidFill>
+                  <a:srgbClr val="FFA500"/>
+                </a:solidFill>
+                <a:latin typeface="Segoe UI"/>
+              </a:defRPr>
+            </a:pPr>
+            <a:r>
+              <a:t>Auto-upgrades for gpt-4o Standard begin Mar 9, 2026. Review your deployments &amp; test with latest versions.</a:t>
+            </a:r>
+          </a:p>
+        </p:txBody>
+      </p:sp>
+    </p:spTree>
+  </p:cSld>
+  <p:clrMapOvr>
+    <a:masterClrMapping/>
+  </p:clrMapOvr>
+</p:sld>
+</file>
+
+<file path=ppt/slides/slide11.xml><?xml version="1.0" encoding="utf-8"?>
+<p:sld xmlns:a="http://schemas.openxmlformats.org/drawingml/2006/main" xmlns:p="http://schemas.openxmlformats.org/presentationml/2006/main" xmlns:r="http://schemas.openxmlformats.org/officeDocument/2006/relationships">
+  <p:cSld>
+    <p:bg>
+      <p:bgPr>
+        <a:solidFill>
+          <a:srgbClr val="1B1B1B"/>
+        </a:solidFill>
+        <a:effectLst/>
+      </p:bgPr>
+    </p:bg>
+    <p:spTree>
+      <p:nvGrpSpPr>
+        <p:cNvPr id="1" name=""/>
+        <p:cNvGrpSpPr/>
+        <p:nvPr/>
+      </p:nvGrpSpPr>
+      <p:grpSpPr/>
+      <p:sp>
+        <p:nvSpPr>
+          <p:cNvPr id="2" name="Rectangle 1"/>
+          <p:cNvSpPr/>
+          <p:nvPr/>
+        </p:nvSpPr>
+        <p:spPr>
+          <a:xfrm>
+            <a:off x="0" y="0"/>
+            <a:ext cx="12191695" cy="137160"/>
+          </a:xfrm>
+          <a:prstGeom prst="rect">
+            <a:avLst/>
+          </a:prstGeom>
+          <a:solidFill>
+            <a:srgbClr val="0078D4"/>
+          </a:solidFill>
+          <a:ln>
+            <a:noFill/>
+          </a:ln>
+        </p:spPr>
+        <p:style>
+          <a:lnRef idx="1">
+            <a:schemeClr val="accent1"/>
+          </a:lnRef>
+          <a:fillRef idx="3">
+            <a:schemeClr val="accent1"/>
+          </a:fillRef>
+          <a:effectRef idx="2">
+            <a:schemeClr val="accent1"/>
+          </a:effectRef>
+          <a:fontRef idx="minor">
+            <a:schemeClr val="lt1"/>
+          </a:fontRef>
+        </p:style>
+        <p:txBody>
+          <a:bodyPr rtlCol="0" anchor="ctr"/>
+          <a:lstStyle/>
+          <a:p>
+            <a:pPr algn="ctr"/>
+          </a:p>
+        </p:txBody>
+      </p:sp>
+      <p:sp>
+        <p:nvSpPr>
+          <p:cNvPr id="3" name="TextBox 2"/>
+          <p:cNvSpPr txBox="1"/>
+          <p:nvPr/>
+        </p:nvSpPr>
+        <p:spPr>
+          <a:xfrm>
+            <a:off x="731520" y="365760"/>
+            <a:ext cx="10058400" cy="640080"/>
+          </a:xfrm>
+          <a:prstGeom prst="rect">
+            <a:avLst/>
+          </a:prstGeom>
+          <a:noFill/>
+        </p:spPr>
+        <p:txBody>
+          <a:bodyPr wrap="square">
+            <a:spAutoFit/>
+          </a:bodyPr>
+          <a:lstStyle/>
+          <a:p>
+            <a:pPr algn="l">
+              <a:defRPr sz="3400" b="1">
+                <a:solidFill>
+                  <a:srgbClr val="FFFFFF"/>
+                </a:solidFill>
+                <a:latin typeface="Segoe UI"/>
+              </a:defRPr>
+            </a:pPr>
+            <a:r>
+              <a:t>Retirement Action Items</a:t>
+            </a:r>
+          </a:p>
+        </p:txBody>
+      </p:sp>
+      <p:sp>
+        <p:nvSpPr>
+          <p:cNvPr id="4" name="Rectangle 3"/>
+          <p:cNvSpPr/>
+          <p:nvPr/>
+        </p:nvSpPr>
+        <p:spPr>
+          <a:xfrm>
+            <a:off x="457200" y="1005840"/>
+            <a:ext cx="1097280" cy="50800"/>
+          </a:xfrm>
+          <a:prstGeom prst="rect">
+            <a:avLst/>
+          </a:prstGeom>
+          <a:solidFill>
+            <a:srgbClr val="0078D4"/>
+          </a:solidFill>
+          <a:ln>
+            <a:noFill/>
+          </a:ln>
+        </p:spPr>
+        <p:style>
+          <a:lnRef idx="1">
+            <a:schemeClr val="accent1"/>
+          </a:lnRef>
+          <a:fillRef idx="3">
+            <a:schemeClr val="accent1"/>
+          </a:fillRef>
+          <a:effectRef idx="2">
+            <a:schemeClr val="accent1"/>
+          </a:effectRef>
+          <a:fontRef idx="minor">
+            <a:schemeClr val="lt1"/>
+          </a:fontRef>
+        </p:style>
+        <p:txBody>
+          <a:bodyPr rtlCol="0" anchor="ctr"/>
+          <a:lstStyle/>
+          <a:p>
+            <a:pPr algn="ctr"/>
+          </a:p>
+        </p:txBody>
+      </p:sp>
+      <p:sp>
+        <p:nvSpPr>
+          <p:cNvPr id="5" name="TextBox 4"/>
+          <p:cNvSpPr txBox="1"/>
+          <p:nvPr/>
+        </p:nvSpPr>
+        <p:spPr>
+          <a:xfrm>
+            <a:off x="731520" y="1371600"/>
+            <a:ext cx="10515600" cy="4572000"/>
+          </a:xfrm>
+          <a:prstGeom prst="rect">
+            <a:avLst/>
+          </a:prstGeom>
+          <a:noFill/>
+        </p:spPr>
+        <p:txBody>
+          <a:bodyPr wrap="square">
+            <a:spAutoFit/>
+          </a:bodyPr>
+          <a:lstStyle/>
+          <a:p>
+            <a:pPr>
+              <a:spcBef>
+                <a:spcPts val="800"/>
+              </a:spcBef>
+              <a:spcAft>
+                <a:spcPts val="400"/>
+              </a:spcAft>
+            </a:pPr>
+            <a:r>
+              <a:rPr sz="1600" b="1">
+                <a:solidFill>
+                  <a:srgbClr val="0078D4"/>
+                </a:solidFill>
+                <a:latin typeface="Segoe UI"/>
+              </a:rPr>
+              <a:t>Audit Current Deployments</a:t>
+            </a:r>
+            <a:r>
+              <a:rPr sz="1400" b="0">
+                <a:solidFill>
+                  <a:srgbClr val="FFFFFF"/>
+                </a:solidFill>
+                <a:latin typeface="Segoe UI"/>
+              </a:rPr>
+              <a:t>
+Identify all deployments using deprecated or soon-to-retire model versions. Prioritise gpt-4o Standard and o1 workloads.</a:t>
+            </a:r>
+          </a:p>
+          <a:p>
+            <a:pPr>
+              <a:spcBef>
+                <a:spcPts val="800"/>
+              </a:spcBef>
+              <a:spcAft>
+                <a:spcPts val="400"/>
+              </a:spcAft>
+            </a:pPr>
+            <a:r>
+              <a:rPr sz="1600" b="1">
+                <a:solidFill>
+                  <a:srgbClr val="0078D4"/>
+                </a:solidFill>
+                <a:latin typeface="Segoe UI"/>
+              </a:rPr>
+              <a:t>Test with Latest GA Versions</a:t>
+            </a:r>
+            <a:r>
+              <a:rPr sz="1400" b="0">
+                <a:solidFill>
+                  <a:srgbClr val="FFFFFF"/>
+                </a:solidFill>
+                <a:latin typeface="Segoe UI"/>
+              </a:rPr>
+              <a:t>
+Validate application behaviour on current GA models before auto-upgrades take effect (gpt-4o auto-upgrade starts Mar 9, 2026).</a:t>
+            </a:r>
+          </a:p>
+          <a:p>
+            <a:pPr>
+              <a:spcBef>
+                <a:spcPts val="800"/>
+              </a:spcBef>
+              <a:spcAft>
+                <a:spcPts val="400"/>
+              </a:spcAft>
+            </a:pPr>
+            <a:r>
+              <a:rPr sz="1600" b="1">
+                <a:solidFill>
+                  <a:srgbClr val="0078D4"/>
+                </a:solidFill>
+                <a:latin typeface="Segoe UI"/>
+              </a:rPr>
+              <a:t>Migrate Fine-Tuned Models</a:t>
+            </a:r>
+            <a:r>
+              <a:rPr sz="1400" b="0">
+                <a:solidFill>
+                  <a:srgbClr val="FFFFFF"/>
+                </a:solidFill>
+                <a:latin typeface="Segoe UI"/>
+              </a:rPr>
+              <a:t>
+Fine-tuned deployments on retired bases are NOT auto-upgraded. Re-train on a supported base model before the retirement date.</a:t>
+            </a:r>
+          </a:p>
+          <a:p>
+            <a:pPr>
+              <a:spcBef>
+                <a:spcPts val="800"/>
+              </a:spcBef>
+              <a:spcAft>
+                <a:spcPts val="400"/>
+              </a:spcAft>
+            </a:pPr>
+            <a:r>
+              <a:rPr sz="1600" b="1">
+                <a:solidFill>
+                  <a:srgbClr val="0078D4"/>
+                </a:solidFill>
+                <a:latin typeface="Segoe UI"/>
+              </a:rPr>
+              <a:t>Monitor the Retirements Page</a:t>
+            </a:r>
+            <a:r>
+              <a:rPr sz="1400" b="0">
+                <a:solidFill>
+                  <a:srgbClr val="FFFFFF"/>
+                </a:solidFill>
+                <a:latin typeface="Segoe UI"/>
+              </a:rPr>
+              <a:t>
+Bookmark learn.microsoft.com/azure/ai-foundry/openai/concepts/model-retirements for the latest schedule and replacement recommendations.</a:t>
+            </a:r>
+          </a:p>
+        </p:txBody>
+      </p:sp>
+    </p:spTree>
+  </p:cSld>
+  <p:clrMapOvr>
+    <a:masterClrMapping/>
+  </p:clrMapOvr>
+</p:sld>
+</file>
+
+<file path=ppt/slides/slide12.xml><?xml version="1.0" encoding="utf-8"?>
 <p:sld xmlns:a="http://schemas.openxmlformats.org/drawingml/2006/main" xmlns:p="http://schemas.openxmlformats.org/presentationml/2006/main" xmlns:r="http://schemas.openxmlformats.org/officeDocument/2006/relationships">
   <p:cSld>
     <p:bg>
@@ -4324,7 +5577,7 @@
 </p:sld>
 </file>
 
-<file path=ppt/slides/slide11.xml><?xml version="1.0" encoding="utf-8"?>
+<file path=ppt/slides/slide13.xml><?xml version="1.0" encoding="utf-8"?>
 <p:sld xmlns:a="http://schemas.openxmlformats.org/drawingml/2006/main" xmlns:p="http://schemas.openxmlformats.org/presentationml/2006/main" xmlns:r="http://schemas.openxmlformats.org/officeDocument/2006/relationships">
   <p:cSld>
     <p:bg>
@@ -4711,7 +5964,7 @@
               </a:defRPr>
             </a:pPr>
             <a:r>
-              <a:t>Azure AI Blog</a:t>
+              <a:t>Model Retirements</a:t>
             </a:r>
           </a:p>
         </p:txBody>
@@ -4747,7 +6000,7 @@
               </a:defRPr>
             </a:pPr>
             <a:r>
-              <a:t>https://azure.microsoft.com/en-us/blog/category/ai-machine-learning/</a:t>
+              <a:t>https://learn.microsoft.com/en-us/azure/ai-foundry/openai/concepts/model-retirements</a:t>
             </a:r>
           </a:p>
         </p:txBody>
@@ -4783,7 +6036,7 @@
               </a:defRPr>
             </a:pPr>
             <a:r>
-              <a:t>Foundry Tech Community</a:t>
+              <a:t>Azure AI Blog</a:t>
             </a:r>
           </a:p>
         </p:txBody>
@@ -4819,7 +6072,7 @@
               </a:defRPr>
             </a:pPr>
             <a:r>
-              <a:t>https://techcommunity.microsoft.com/category/azure-ai-foundry/blog/azure-ai-foundry-blog/</a:t>
+              <a:t>https://azure.microsoft.com/en-us/blog/category/ai-machine-learning/</a:t>
             </a:r>
           </a:p>
         </p:txBody>
@@ -4855,7 +6108,7 @@
               </a:defRPr>
             </a:pPr>
             <a:r>
-              <a:t>Foundry Models Catalog</a:t>
+              <a:t>Foundry Tech Community</a:t>
             </a:r>
           </a:p>
         </p:txBody>
@@ -4891,7 +6144,7 @@
               </a:defRPr>
             </a:pPr>
             <a:r>
-              <a:t>https://azure.microsoft.com/en-us/products/ai-foundry/models/</a:t>
+              <a:t>https://techcommunity.microsoft.com/category/azure-ai-foundry/blog/azure-ai-foundry-blog/</a:t>
             </a:r>
           </a:p>
         </p:txBody>
@@ -4927,7 +6180,7 @@
               </a:defRPr>
             </a:pPr>
             <a:r>
-              <a:t>Foundry Agent Service</a:t>
+              <a:t>Foundry Models Catalog</a:t>
             </a:r>
           </a:p>
         </p:txBody>
@@ -4963,7 +6216,7 @@
               </a:defRPr>
             </a:pPr>
             <a:r>
-              <a:t>https://azure.microsoft.com/en-us/products/ai-foundry/agent-service/</a:t>
+              <a:t>https://azure.microsoft.com/en-us/products/ai-foundry/models/</a:t>
             </a:r>
           </a:p>
         </p:txBody>
@@ -4999,7 +6252,7 @@
               </a:defRPr>
             </a:pPr>
             <a:r>
-              <a:t>Azure Updates Feed</a:t>
+              <a:t>Foundry Agent Service</a:t>
             </a:r>
           </a:p>
         </p:txBody>
@@ -5013,6 +6266,78 @@
         <p:spPr>
           <a:xfrm>
             <a:off x="4754880" y="4983480"/>
+            <a:ext cx="6858000" cy="365760"/>
+          </a:xfrm>
+          <a:prstGeom prst="rect">
+            <a:avLst/>
+          </a:prstGeom>
+          <a:noFill/>
+        </p:spPr>
+        <p:txBody>
+          <a:bodyPr wrap="square">
+            <a:spAutoFit/>
+          </a:bodyPr>
+          <a:lstStyle/>
+          <a:p>
+            <a:pPr algn="l">
+              <a:defRPr sz="1400" b="0">
+                <a:solidFill>
+                  <a:srgbClr val="CCCCCC"/>
+                </a:solidFill>
+                <a:latin typeface="Segoe UI"/>
+              </a:defRPr>
+            </a:pPr>
+            <a:r>
+              <a:t>https://azure.microsoft.com/en-us/products/ai-foundry/agent-service/</a:t>
+            </a:r>
+          </a:p>
+        </p:txBody>
+      </p:sp>
+      <p:sp>
+        <p:nvSpPr>
+          <p:cNvPr id="21" name="TextBox 20"/>
+          <p:cNvSpPr txBox="1"/>
+          <p:nvPr/>
+        </p:nvSpPr>
+        <p:spPr>
+          <a:xfrm>
+            <a:off x="914400" y="5486400"/>
+            <a:ext cx="3657600" cy="365760"/>
+          </a:xfrm>
+          <a:prstGeom prst="rect">
+            <a:avLst/>
+          </a:prstGeom>
+          <a:noFill/>
+        </p:spPr>
+        <p:txBody>
+          <a:bodyPr wrap="square">
+            <a:spAutoFit/>
+          </a:bodyPr>
+          <a:lstStyle/>
+          <a:p>
+            <a:pPr algn="l">
+              <a:defRPr sz="1600" b="1">
+                <a:solidFill>
+                  <a:srgbClr val="0078D4"/>
+                </a:solidFill>
+                <a:latin typeface="Segoe UI"/>
+              </a:defRPr>
+            </a:pPr>
+            <a:r>
+              <a:t>Azure Updates Feed</a:t>
+            </a:r>
+          </a:p>
+        </p:txBody>
+      </p:sp>
+      <p:sp>
+        <p:nvSpPr>
+          <p:cNvPr id="22" name="TextBox 21"/>
+          <p:cNvSpPr txBox="1"/>
+          <p:nvPr/>
+        </p:nvSpPr>
+        <p:spPr>
+          <a:xfrm>
+            <a:off x="4754880" y="5486400"/>
             <a:ext cx="6858000" cy="365760"/>
           </a:xfrm>
           <a:prstGeom prst="rect">
@@ -5048,7 +6373,7 @@
 </p:sld>
 </file>
 
-<file path=ppt/slides/slide12.xml><?xml version="1.0" encoding="utf-8"?>
+<file path=ppt/slides/slide14.xml><?xml version="1.0" encoding="utf-8"?>
 <p:sld xmlns:a="http://schemas.openxmlformats.org/drawingml/2006/main" xmlns:p="http://schemas.openxmlformats.org/presentationml/2006/main" xmlns:r="http://schemas.openxmlformats.org/officeDocument/2006/relationships">
   <p:cSld>
     <p:bg>
@@ -5770,6 +7095,78 @@
         <p:spPr>
           <a:xfrm>
             <a:off x="1463040" y="4617720"/>
+            <a:ext cx="9144000" cy="457200"/>
+          </a:xfrm>
+          <a:prstGeom prst="rect">
+            <a:avLst/>
+          </a:prstGeom>
+          <a:noFill/>
+        </p:spPr>
+        <p:txBody>
+          <a:bodyPr wrap="square">
+            <a:spAutoFit/>
+          </a:bodyPr>
+          <a:lstStyle/>
+          <a:p>
+            <a:pPr algn="l">
+              <a:defRPr sz="2000" b="0">
+                <a:solidFill>
+                  <a:srgbClr val="FFFFFF"/>
+                </a:solidFill>
+                <a:latin typeface="Segoe UI"/>
+              </a:defRPr>
+            </a:pPr>
+            <a:r>
+              <a:t>Model Deprecations &amp; Retirements</a:t>
+            </a:r>
+          </a:p>
+        </p:txBody>
+      </p:sp>
+      <p:sp>
+        <p:nvSpPr>
+          <p:cNvPr id="17" name="TextBox 16"/>
+          <p:cNvSpPr txBox="1"/>
+          <p:nvPr/>
+        </p:nvSpPr>
+        <p:spPr>
+          <a:xfrm>
+            <a:off x="914400" y="5212080"/>
+            <a:ext cx="457200" cy="457200"/>
+          </a:xfrm>
+          <a:prstGeom prst="rect">
+            <a:avLst/>
+          </a:prstGeom>
+          <a:noFill/>
+        </p:spPr>
+        <p:txBody>
+          <a:bodyPr wrap="square">
+            <a:spAutoFit/>
+          </a:bodyPr>
+          <a:lstStyle/>
+          <a:p>
+            <a:pPr algn="l">
+              <a:defRPr sz="2000" b="1">
+                <a:solidFill>
+                  <a:srgbClr val="0078D4"/>
+                </a:solidFill>
+                <a:latin typeface="Segoe UI"/>
+              </a:defRPr>
+            </a:pPr>
+            <a:r>
+              <a:t>7.</a:t>
+            </a:r>
+          </a:p>
+        </p:txBody>
+      </p:sp>
+      <p:sp>
+        <p:nvSpPr>
+          <p:cNvPr id="18" name="TextBox 17"/>
+          <p:cNvSpPr txBox="1"/>
+          <p:nvPr/>
+        </p:nvSpPr>
+        <p:spPr>
+          <a:xfrm>
+            <a:off x="1463040" y="5212080"/>
             <a:ext cx="9144000" cy="457200"/>
           </a:xfrm>
           <a:prstGeom prst="rect">

</xml_diff>